<commit_message>
add new & update ppts
</commit_message>
<xml_diff>
--- a/宣道詩/(宣道詩129) 日日祈求.pptx
+++ b/宣道詩/(宣道詩129) 日日祈求.pptx
@@ -322,6 +322,11 @@
         </p:txBody>
       </p:sp>
     </p:spTree>
+    <p:extLst>
+      <p:ext uri="{BB962C8B-B14F-4D97-AF65-F5344CB8AC3E}">
+        <p14:creationId xmlns:p14="http://schemas.microsoft.com/office/powerpoint/2010/main" val="1"/>
+      </p:ext>
+    </p:extLst>
   </p:cSld>
   <p:clrMap bg1="lt1" tx1="dk1" bg2="lt2" tx2="dk2" accent1="accent1" accent2="accent2" accent3="accent3" accent4="accent4" accent5="accent5" accent6="accent6" hlink="hlink" folHlink="folHlink"/>
 </p:handoutMaster>
@@ -471,38 +476,37 @@
           <a:p>
             <a:pPr lvl="0"/>
             <a:r>
-              <a:rPr lang="zh-TW" altLang="en-US" smtClean="0"/>
+              <a:rPr lang="zh-TW" altLang="en-US"/>
               <a:t>按一下以編輯母片文字樣式</a:t>
             </a:r>
           </a:p>
           <a:p>
             <a:pPr lvl="1"/>
             <a:r>
-              <a:rPr lang="zh-TW" altLang="en-US" smtClean="0"/>
+              <a:rPr lang="zh-TW" altLang="en-US"/>
               <a:t>第二層</a:t>
             </a:r>
           </a:p>
           <a:p>
             <a:pPr lvl="2"/>
             <a:r>
-              <a:rPr lang="zh-TW" altLang="en-US" smtClean="0"/>
+              <a:rPr lang="zh-TW" altLang="en-US"/>
               <a:t>第三層</a:t>
             </a:r>
           </a:p>
           <a:p>
             <a:pPr lvl="3"/>
             <a:r>
-              <a:rPr lang="zh-TW" altLang="en-US" smtClean="0"/>
+              <a:rPr lang="zh-TW" altLang="en-US"/>
               <a:t>第四層</a:t>
             </a:r>
           </a:p>
           <a:p>
             <a:pPr lvl="4"/>
             <a:r>
-              <a:rPr lang="zh-TW" altLang="en-US" smtClean="0"/>
+              <a:rPr lang="zh-TW" altLang="en-US"/>
               <a:t>第五層</a:t>
             </a:r>
-            <a:endParaRPr lang="zh-TW" altLang="en-US"/>
           </a:p>
         </p:txBody>
       </p:sp>
@@ -708,7 +712,7 @@
           <a:lstStyle/>
           <a:p>
             <a:r>
-              <a:rPr lang="en-US" altLang="zh-TW" smtClean="0"/>
+              <a:rPr lang="en-US" altLang="zh-TW"/>
               <a:t>Click to edit Master title style</a:t>
             </a:r>
             <a:endParaRPr lang="zh-TW" altLang="en-US"/>
@@ -827,7 +831,7 @@
           </a:lstStyle>
           <a:p>
             <a:r>
-              <a:rPr lang="en-US" altLang="zh-TW" smtClean="0"/>
+              <a:rPr lang="en-US" altLang="zh-TW"/>
               <a:t>Click to edit Master subtitle style</a:t>
             </a:r>
             <a:endParaRPr lang="zh-TW" altLang="en-US"/>
@@ -950,7 +954,7 @@
           <a:lstStyle/>
           <a:p>
             <a:r>
-              <a:rPr lang="en-US" altLang="zh-TW" smtClean="0"/>
+              <a:rPr lang="en-US" altLang="zh-TW"/>
               <a:t>Click to edit Master title style</a:t>
             </a:r>
             <a:endParaRPr lang="zh-TW" altLang="en-US"/>
@@ -974,35 +978,35 @@
           <a:p>
             <a:pPr lvl="0"/>
             <a:r>
-              <a:rPr lang="en-US" altLang="zh-TW" smtClean="0"/>
+              <a:rPr lang="en-US" altLang="zh-TW"/>
               <a:t>Edit Master text styles</a:t>
             </a:r>
           </a:p>
           <a:p>
             <a:pPr lvl="1"/>
             <a:r>
-              <a:rPr lang="en-US" altLang="zh-TW" smtClean="0"/>
+              <a:rPr lang="en-US" altLang="zh-TW"/>
               <a:t>Second level</a:t>
             </a:r>
           </a:p>
           <a:p>
             <a:pPr lvl="2"/>
             <a:r>
-              <a:rPr lang="en-US" altLang="zh-TW" smtClean="0"/>
+              <a:rPr lang="en-US" altLang="zh-TW"/>
               <a:t>Third level</a:t>
             </a:r>
           </a:p>
           <a:p>
             <a:pPr lvl="3"/>
             <a:r>
-              <a:rPr lang="en-US" altLang="zh-TW" smtClean="0"/>
+              <a:rPr lang="en-US" altLang="zh-TW"/>
               <a:t>Fourth level</a:t>
             </a:r>
           </a:p>
           <a:p>
             <a:pPr lvl="4"/>
             <a:r>
-              <a:rPr lang="en-US" altLang="zh-TW" smtClean="0"/>
+              <a:rPr lang="en-US" altLang="zh-TW"/>
               <a:t>Fifth level</a:t>
             </a:r>
             <a:endParaRPr lang="zh-TW" altLang="en-US"/>
@@ -1130,7 +1134,7 @@
           <a:lstStyle/>
           <a:p>
             <a:r>
-              <a:rPr lang="en-US" altLang="zh-TW" smtClean="0"/>
+              <a:rPr lang="en-US" altLang="zh-TW"/>
               <a:t>Click to edit Master title style</a:t>
             </a:r>
             <a:endParaRPr lang="zh-TW" altLang="en-US"/>
@@ -1159,35 +1163,35 @@
           <a:p>
             <a:pPr lvl="0"/>
             <a:r>
-              <a:rPr lang="en-US" altLang="zh-TW" smtClean="0"/>
+              <a:rPr lang="en-US" altLang="zh-TW"/>
               <a:t>Edit Master text styles</a:t>
             </a:r>
           </a:p>
           <a:p>
             <a:pPr lvl="1"/>
             <a:r>
-              <a:rPr lang="en-US" altLang="zh-TW" smtClean="0"/>
+              <a:rPr lang="en-US" altLang="zh-TW"/>
               <a:t>Second level</a:t>
             </a:r>
           </a:p>
           <a:p>
             <a:pPr lvl="2"/>
             <a:r>
-              <a:rPr lang="en-US" altLang="zh-TW" smtClean="0"/>
+              <a:rPr lang="en-US" altLang="zh-TW"/>
               <a:t>Third level</a:t>
             </a:r>
           </a:p>
           <a:p>
             <a:pPr lvl="3"/>
             <a:r>
-              <a:rPr lang="en-US" altLang="zh-TW" smtClean="0"/>
+              <a:rPr lang="en-US" altLang="zh-TW"/>
               <a:t>Fourth level</a:t>
             </a:r>
           </a:p>
           <a:p>
             <a:pPr lvl="4"/>
             <a:r>
-              <a:rPr lang="en-US" altLang="zh-TW" smtClean="0"/>
+              <a:rPr lang="en-US" altLang="zh-TW"/>
               <a:t>Fifth level</a:t>
             </a:r>
             <a:endParaRPr lang="zh-TW" altLang="en-US"/>
@@ -1310,7 +1314,7 @@
           <a:lstStyle/>
           <a:p>
             <a:r>
-              <a:rPr lang="en-US" altLang="zh-TW" smtClean="0"/>
+              <a:rPr lang="en-US" altLang="zh-TW"/>
               <a:t>Click to edit Master title style</a:t>
             </a:r>
             <a:endParaRPr lang="zh-TW" altLang="en-US"/>
@@ -1334,35 +1338,35 @@
           <a:p>
             <a:pPr lvl="0"/>
             <a:r>
-              <a:rPr lang="en-US" altLang="zh-TW" smtClean="0"/>
+              <a:rPr lang="en-US" altLang="zh-TW"/>
               <a:t>Edit Master text styles</a:t>
             </a:r>
           </a:p>
           <a:p>
             <a:pPr lvl="1"/>
             <a:r>
-              <a:rPr lang="en-US" altLang="zh-TW" smtClean="0"/>
+              <a:rPr lang="en-US" altLang="zh-TW"/>
               <a:t>Second level</a:t>
             </a:r>
           </a:p>
           <a:p>
             <a:pPr lvl="2"/>
             <a:r>
-              <a:rPr lang="en-US" altLang="zh-TW" smtClean="0"/>
+              <a:rPr lang="en-US" altLang="zh-TW"/>
               <a:t>Third level</a:t>
             </a:r>
           </a:p>
           <a:p>
             <a:pPr lvl="3"/>
             <a:r>
-              <a:rPr lang="en-US" altLang="zh-TW" smtClean="0"/>
+              <a:rPr lang="en-US" altLang="zh-TW"/>
               <a:t>Fourth level</a:t>
             </a:r>
           </a:p>
           <a:p>
             <a:pPr lvl="4"/>
             <a:r>
-              <a:rPr lang="en-US" altLang="zh-TW" smtClean="0"/>
+              <a:rPr lang="en-US" altLang="zh-TW"/>
               <a:t>Fifth level</a:t>
             </a:r>
             <a:endParaRPr lang="zh-TW" altLang="en-US"/>
@@ -1494,7 +1498,7 @@
           </a:lstStyle>
           <a:p>
             <a:r>
-              <a:rPr lang="en-US" altLang="zh-TW" smtClean="0"/>
+              <a:rPr lang="en-US" altLang="zh-TW"/>
               <a:t>Click to edit Master title style</a:t>
             </a:r>
             <a:endParaRPr lang="zh-TW" altLang="en-US"/>
@@ -1614,7 +1618,7 @@
           <a:p>
             <a:pPr lvl="0"/>
             <a:r>
-              <a:rPr lang="en-US" altLang="zh-TW" smtClean="0"/>
+              <a:rPr lang="en-US" altLang="zh-TW"/>
               <a:t>Edit Master text styles</a:t>
             </a:r>
           </a:p>
@@ -1736,7 +1740,7 @@
           <a:lstStyle/>
           <a:p>
             <a:r>
-              <a:rPr lang="en-US" altLang="zh-TW" smtClean="0"/>
+              <a:rPr lang="en-US" altLang="zh-TW"/>
               <a:t>Click to edit Master title style</a:t>
             </a:r>
             <a:endParaRPr lang="zh-TW" altLang="en-US"/>
@@ -1793,35 +1797,35 @@
           <a:p>
             <a:pPr lvl="0"/>
             <a:r>
-              <a:rPr lang="en-US" altLang="zh-TW" smtClean="0"/>
+              <a:rPr lang="en-US" altLang="zh-TW"/>
               <a:t>Edit Master text styles</a:t>
             </a:r>
           </a:p>
           <a:p>
             <a:pPr lvl="1"/>
             <a:r>
-              <a:rPr lang="en-US" altLang="zh-TW" smtClean="0"/>
+              <a:rPr lang="en-US" altLang="zh-TW"/>
               <a:t>Second level</a:t>
             </a:r>
           </a:p>
           <a:p>
             <a:pPr lvl="2"/>
             <a:r>
-              <a:rPr lang="en-US" altLang="zh-TW" smtClean="0"/>
+              <a:rPr lang="en-US" altLang="zh-TW"/>
               <a:t>Third level</a:t>
             </a:r>
           </a:p>
           <a:p>
             <a:pPr lvl="3"/>
             <a:r>
-              <a:rPr lang="en-US" altLang="zh-TW" smtClean="0"/>
+              <a:rPr lang="en-US" altLang="zh-TW"/>
               <a:t>Fourth level</a:t>
             </a:r>
           </a:p>
           <a:p>
             <a:pPr lvl="4"/>
             <a:r>
-              <a:rPr lang="en-US" altLang="zh-TW" smtClean="0"/>
+              <a:rPr lang="en-US" altLang="zh-TW"/>
               <a:t>Fifth level</a:t>
             </a:r>
             <a:endParaRPr lang="zh-TW" altLang="en-US"/>
@@ -1878,35 +1882,35 @@
           <a:p>
             <a:pPr lvl="0"/>
             <a:r>
-              <a:rPr lang="en-US" altLang="zh-TW" smtClean="0"/>
+              <a:rPr lang="en-US" altLang="zh-TW"/>
               <a:t>Edit Master text styles</a:t>
             </a:r>
           </a:p>
           <a:p>
             <a:pPr lvl="1"/>
             <a:r>
-              <a:rPr lang="en-US" altLang="zh-TW" smtClean="0"/>
+              <a:rPr lang="en-US" altLang="zh-TW"/>
               <a:t>Second level</a:t>
             </a:r>
           </a:p>
           <a:p>
             <a:pPr lvl="2"/>
             <a:r>
-              <a:rPr lang="en-US" altLang="zh-TW" smtClean="0"/>
+              <a:rPr lang="en-US" altLang="zh-TW"/>
               <a:t>Third level</a:t>
             </a:r>
           </a:p>
           <a:p>
             <a:pPr lvl="3"/>
             <a:r>
-              <a:rPr lang="en-US" altLang="zh-TW" smtClean="0"/>
+              <a:rPr lang="en-US" altLang="zh-TW"/>
               <a:t>Fourth level</a:t>
             </a:r>
           </a:p>
           <a:p>
             <a:pPr lvl="4"/>
             <a:r>
-              <a:rPr lang="en-US" altLang="zh-TW" smtClean="0"/>
+              <a:rPr lang="en-US" altLang="zh-TW"/>
               <a:t>Fifth level</a:t>
             </a:r>
             <a:endParaRPr lang="zh-TW" altLang="en-US"/>
@@ -2033,7 +2037,7 @@
           </a:lstStyle>
           <a:p>
             <a:r>
-              <a:rPr lang="en-US" altLang="zh-TW" smtClean="0"/>
+              <a:rPr lang="en-US" altLang="zh-TW"/>
               <a:t>Click to edit Master title style</a:t>
             </a:r>
             <a:endParaRPr lang="zh-TW" altLang="en-US"/>
@@ -2099,7 +2103,7 @@
           <a:p>
             <a:pPr lvl="0"/>
             <a:r>
-              <a:rPr lang="en-US" altLang="zh-TW" smtClean="0"/>
+              <a:rPr lang="en-US" altLang="zh-TW"/>
               <a:t>Edit Master text styles</a:t>
             </a:r>
           </a:p>
@@ -2155,35 +2159,35 @@
           <a:p>
             <a:pPr lvl="0"/>
             <a:r>
-              <a:rPr lang="en-US" altLang="zh-TW" smtClean="0"/>
+              <a:rPr lang="en-US" altLang="zh-TW"/>
               <a:t>Edit Master text styles</a:t>
             </a:r>
           </a:p>
           <a:p>
             <a:pPr lvl="1"/>
             <a:r>
-              <a:rPr lang="en-US" altLang="zh-TW" smtClean="0"/>
+              <a:rPr lang="en-US" altLang="zh-TW"/>
               <a:t>Second level</a:t>
             </a:r>
           </a:p>
           <a:p>
             <a:pPr lvl="2"/>
             <a:r>
-              <a:rPr lang="en-US" altLang="zh-TW" smtClean="0"/>
+              <a:rPr lang="en-US" altLang="zh-TW"/>
               <a:t>Third level</a:t>
             </a:r>
           </a:p>
           <a:p>
             <a:pPr lvl="3"/>
             <a:r>
-              <a:rPr lang="en-US" altLang="zh-TW" smtClean="0"/>
+              <a:rPr lang="en-US" altLang="zh-TW"/>
               <a:t>Fourth level</a:t>
             </a:r>
           </a:p>
           <a:p>
             <a:pPr lvl="4"/>
             <a:r>
-              <a:rPr lang="en-US" altLang="zh-TW" smtClean="0"/>
+              <a:rPr lang="en-US" altLang="zh-TW"/>
               <a:t>Fifth level</a:t>
             </a:r>
             <a:endParaRPr lang="zh-TW" altLang="en-US"/>
@@ -2249,7 +2253,7 @@
           <a:p>
             <a:pPr lvl="0"/>
             <a:r>
-              <a:rPr lang="en-US" altLang="zh-TW" smtClean="0"/>
+              <a:rPr lang="en-US" altLang="zh-TW"/>
               <a:t>Edit Master text styles</a:t>
             </a:r>
           </a:p>
@@ -2305,35 +2309,35 @@
           <a:p>
             <a:pPr lvl="0"/>
             <a:r>
-              <a:rPr lang="en-US" altLang="zh-TW" smtClean="0"/>
+              <a:rPr lang="en-US" altLang="zh-TW"/>
               <a:t>Edit Master text styles</a:t>
             </a:r>
           </a:p>
           <a:p>
             <a:pPr lvl="1"/>
             <a:r>
-              <a:rPr lang="en-US" altLang="zh-TW" smtClean="0"/>
+              <a:rPr lang="en-US" altLang="zh-TW"/>
               <a:t>Second level</a:t>
             </a:r>
           </a:p>
           <a:p>
             <a:pPr lvl="2"/>
             <a:r>
-              <a:rPr lang="en-US" altLang="zh-TW" smtClean="0"/>
+              <a:rPr lang="en-US" altLang="zh-TW"/>
               <a:t>Third level</a:t>
             </a:r>
           </a:p>
           <a:p>
             <a:pPr lvl="3"/>
             <a:r>
-              <a:rPr lang="en-US" altLang="zh-TW" smtClean="0"/>
+              <a:rPr lang="en-US" altLang="zh-TW"/>
               <a:t>Fourth level</a:t>
             </a:r>
           </a:p>
           <a:p>
             <a:pPr lvl="4"/>
             <a:r>
-              <a:rPr lang="en-US" altLang="zh-TW" smtClean="0"/>
+              <a:rPr lang="en-US" altLang="zh-TW"/>
               <a:t>Fifth level</a:t>
             </a:r>
             <a:endParaRPr lang="zh-TW" altLang="en-US"/>
@@ -2456,7 +2460,7 @@
           <a:lstStyle/>
           <a:p>
             <a:r>
-              <a:rPr lang="en-US" altLang="zh-TW" smtClean="0"/>
+              <a:rPr lang="en-US" altLang="zh-TW"/>
               <a:t>Click to edit Master title style</a:t>
             </a:r>
             <a:endParaRPr lang="zh-TW" altLang="en-US"/>
@@ -2688,7 +2692,7 @@
           </a:lstStyle>
           <a:p>
             <a:r>
-              <a:rPr lang="en-US" altLang="zh-TW" smtClean="0"/>
+              <a:rPr lang="en-US" altLang="zh-TW"/>
               <a:t>Click to edit Master title style</a:t>
             </a:r>
             <a:endParaRPr lang="zh-TW" altLang="en-US"/>
@@ -2745,35 +2749,35 @@
           <a:p>
             <a:pPr lvl="0"/>
             <a:r>
-              <a:rPr lang="en-US" altLang="zh-TW" smtClean="0"/>
+              <a:rPr lang="en-US" altLang="zh-TW"/>
               <a:t>Edit Master text styles</a:t>
             </a:r>
           </a:p>
           <a:p>
             <a:pPr lvl="1"/>
             <a:r>
-              <a:rPr lang="en-US" altLang="zh-TW" smtClean="0"/>
+              <a:rPr lang="en-US" altLang="zh-TW"/>
               <a:t>Second level</a:t>
             </a:r>
           </a:p>
           <a:p>
             <a:pPr lvl="2"/>
             <a:r>
-              <a:rPr lang="en-US" altLang="zh-TW" smtClean="0"/>
+              <a:rPr lang="en-US" altLang="zh-TW"/>
               <a:t>Third level</a:t>
             </a:r>
           </a:p>
           <a:p>
             <a:pPr lvl="3"/>
             <a:r>
-              <a:rPr lang="en-US" altLang="zh-TW" smtClean="0"/>
+              <a:rPr lang="en-US" altLang="zh-TW"/>
               <a:t>Fourth level</a:t>
             </a:r>
           </a:p>
           <a:p>
             <a:pPr lvl="4"/>
             <a:r>
-              <a:rPr lang="en-US" altLang="zh-TW" smtClean="0"/>
+              <a:rPr lang="en-US" altLang="zh-TW"/>
               <a:t>Fifth level</a:t>
             </a:r>
             <a:endParaRPr lang="zh-TW" altLang="en-US"/>
@@ -2839,7 +2843,7 @@
           <a:p>
             <a:pPr lvl="0"/>
             <a:r>
-              <a:rPr lang="en-US" altLang="zh-TW" smtClean="0"/>
+              <a:rPr lang="en-US" altLang="zh-TW"/>
               <a:t>Edit Master text styles</a:t>
             </a:r>
           </a:p>
@@ -2970,7 +2974,7 @@
           </a:lstStyle>
           <a:p>
             <a:r>
-              <a:rPr lang="en-US" altLang="zh-TW" smtClean="0"/>
+              <a:rPr lang="en-US" altLang="zh-TW"/>
               <a:t>Click to edit Master title style</a:t>
             </a:r>
             <a:endParaRPr lang="zh-TW" altLang="en-US"/>
@@ -3035,7 +3039,7 @@
           </a:lstStyle>
           <a:p>
             <a:r>
-              <a:rPr lang="en-US" altLang="zh-TW" smtClean="0"/>
+              <a:rPr lang="en-US" altLang="zh-TW"/>
               <a:t>Click icon to add picture</a:t>
             </a:r>
             <a:endParaRPr lang="zh-TW" altLang="en-US"/>
@@ -3101,7 +3105,7 @@
           <a:p>
             <a:pPr lvl="0"/>
             <a:r>
-              <a:rPr lang="en-US" altLang="zh-TW" smtClean="0"/>
+              <a:rPr lang="en-US" altLang="zh-TW"/>
               <a:t>Edit Master text styles</a:t>
             </a:r>
           </a:p>
@@ -3243,10 +3247,9 @@
           <a:lstStyle/>
           <a:p>
             <a:r>
-              <a:rPr lang="zh-TW" altLang="en-US" smtClean="0"/>
+              <a:rPr lang="zh-TW" altLang="en-US"/>
               <a:t>按一下以編輯母片標題樣式</a:t>
             </a:r>
-            <a:endParaRPr lang="zh-TW" altLang="en-US"/>
           </a:p>
         </p:txBody>
       </p:sp>
@@ -3277,38 +3280,37 @@
           <a:p>
             <a:pPr lvl="0"/>
             <a:r>
-              <a:rPr lang="zh-TW" altLang="en-US" smtClean="0"/>
+              <a:rPr lang="zh-TW" altLang="en-US"/>
               <a:t>按一下以編輯母片文字樣式</a:t>
             </a:r>
           </a:p>
           <a:p>
             <a:pPr lvl="1"/>
             <a:r>
-              <a:rPr lang="zh-TW" altLang="en-US" smtClean="0"/>
+              <a:rPr lang="zh-TW" altLang="en-US"/>
               <a:t>第二層</a:t>
             </a:r>
           </a:p>
           <a:p>
             <a:pPr lvl="2"/>
             <a:r>
-              <a:rPr lang="zh-TW" altLang="en-US" smtClean="0"/>
+              <a:rPr lang="zh-TW" altLang="en-US"/>
               <a:t>第三層</a:t>
             </a:r>
           </a:p>
           <a:p>
             <a:pPr lvl="3"/>
             <a:r>
-              <a:rPr lang="zh-TW" altLang="en-US" smtClean="0"/>
+              <a:rPr lang="zh-TW" altLang="en-US"/>
               <a:t>第四層</a:t>
             </a:r>
           </a:p>
           <a:p>
             <a:pPr lvl="4"/>
             <a:r>
-              <a:rPr lang="zh-TW" altLang="en-US" smtClean="0"/>
+              <a:rPr lang="zh-TW" altLang="en-US"/>
               <a:t>第五層</a:t>
             </a:r>
-            <a:endParaRPr lang="zh-TW" altLang="en-US"/>
           </a:p>
         </p:txBody>
       </p:sp>
@@ -3783,23 +3785,6 @@
               </a:rPr>
               <a:t>129</a:t>
             </a:r>
-            <a:r>
-              <a:rPr lang="en-US" altLang="zh-CN" sz="7200" b="1" i="1" dirty="0">
-                <a:solidFill>
-                  <a:srgbClr val="660033"/>
-                </a:solidFill>
-                <a:effectLst>
-                  <a:outerShdw blurRad="38100" dist="38100" dir="2700000" algn="tl">
-                    <a:srgbClr val="000000">
-                      <a:alpha val="43137"/>
-                    </a:srgbClr>
-                  </a:outerShdw>
-                </a:effectLst>
-                <a:latin typeface="微軟正黑體" pitchFamily="34" charset="-120"/>
-                <a:ea typeface="微軟正黑體" pitchFamily="34" charset="-120"/>
-              </a:rPr>
-              <a:t/>
-            </a:r>
             <a:br>
               <a:rPr lang="en-US" altLang="zh-CN" sz="7200" b="1" i="1" dirty="0">
                 <a:solidFill>
@@ -3831,24 +3816,7 @@
                 <a:latin typeface="微軟正黑體" pitchFamily="34" charset="-120"/>
                 <a:ea typeface="微軟正黑體" pitchFamily="34" charset="-120"/>
               </a:rPr>
-              <a:t>日</a:t>
-            </a:r>
-            <a:r>
-              <a:rPr lang="zh-CN" altLang="en-US" sz="8000" b="1" dirty="0">
-                <a:solidFill>
-                  <a:srgbClr val="000066"/>
-                </a:solidFill>
-                <a:effectLst>
-                  <a:outerShdw blurRad="38100" dist="38100" dir="2700000" algn="tl">
-                    <a:srgbClr val="000000">
-                      <a:alpha val="43137"/>
-                    </a:srgbClr>
-                  </a:outerShdw>
-                </a:effectLst>
-                <a:latin typeface="微軟正黑體" pitchFamily="34" charset="-120"/>
-                <a:ea typeface="微軟正黑體" pitchFamily="34" charset="-120"/>
-              </a:rPr>
-              <a:t>日祈求</a:t>
+              <a:t>日日祈求</a:t>
             </a:r>
             <a:endParaRPr lang="zh-TW" altLang="en-US" sz="8000" b="1" dirty="0">
               <a:solidFill>
@@ -3877,13 +3845,6 @@
   <p:clrMapOvr>
     <a:masterClrMapping/>
   </p:clrMapOvr>
-  <p:timing>
-    <p:tnLst>
-      <p:par>
-        <p:cTn id="1" dur="indefinite" restart="never" nodeType="tmRoot"/>
-      </p:par>
-    </p:tnLst>
-  </p:timing>
 </p:sld>
 </file>
 
@@ -3954,13 +3915,6 @@
               </a:rPr>
               <a:t>至我瞬息生命過此世</a:t>
             </a:r>
-            <a:endParaRPr lang="zh-CN" altLang="zh-TW" sz="6400" b="1" dirty="0">
-              <a:solidFill>
-                <a:srgbClr val="000066"/>
-              </a:solidFill>
-              <a:latin typeface="Microsoft JhengHei" panose="020B0604030504040204" pitchFamily="34" charset="-120"/>
-              <a:ea typeface="Microsoft JhengHei" panose="020B0604030504040204" pitchFamily="34" charset="-120"/>
-            </a:endParaRPr>
           </a:p>
         </p:txBody>
       </p:sp>
@@ -3984,42 +3938,26 @@
           <a:bodyPr wrap="square" rtlCol="0" anchor="ctr">
             <a:spAutoFit/>
           </a:bodyPr>
-          <a:lstStyle/>
-          <a:p>
-            <a:pPr algn="ctr"/>
-            <a:r>
-              <a:rPr lang="en-US" sz="4800" b="1" dirty="0">
+          <a:lstStyle>
+            <a:defPPr>
+              <a:defRPr lang="zh-TW"/>
+            </a:defPPr>
+            <a:lvl1pPr algn="ctr">
+              <a:defRPr sz="3600" b="1">
                 <a:solidFill>
                   <a:srgbClr val="000066"/>
                 </a:solidFill>
                 <a:effectLst/>
-              </a:rPr>
-              <a:t>( </a:t>
-            </a:r>
-            <a:r>
-              <a:rPr lang="en-US" sz="4800" b="1" dirty="0">
-                <a:solidFill>
-                  <a:srgbClr val="000066"/>
-                </a:solidFill>
-                <a:effectLst/>
-              </a:rPr>
-              <a:t>3 </a:t>
-            </a:r>
-            <a:r>
-              <a:rPr lang="en-US" sz="4800" b="1" dirty="0">
-                <a:solidFill>
-                  <a:srgbClr val="000066"/>
-                </a:solidFill>
-                <a:effectLst/>
-              </a:rPr>
-              <a:t>)</a:t>
-            </a:r>
-            <a:endParaRPr lang="vi-VN" sz="4800" b="1" dirty="0">
-              <a:solidFill>
-                <a:srgbClr val="000066"/>
-              </a:solidFill>
-              <a:effectLst/>
-            </a:endParaRPr>
+                <a:latin typeface="+mj-lt"/>
+              </a:defRPr>
+            </a:lvl1pPr>
+          </a:lstStyle>
+          <a:p>
+            <a:r>
+              <a:rPr lang="en-US" dirty="0"/>
+              <a:t>( 3 / 3 )</a:t>
+            </a:r>
+            <a:endParaRPr lang="vi-VN" dirty="0"/>
           </a:p>
         </p:txBody>
       </p:sp>
@@ -4033,13 +3971,6 @@
   <p:clrMapOvr>
     <a:masterClrMapping/>
   </p:clrMapOvr>
-  <p:timing>
-    <p:tnLst>
-      <p:par>
-        <p:cTn id="1" dur="indefinite" restart="never" nodeType="tmRoot"/>
-      </p:par>
-    </p:tnLst>
-  </p:timing>
 </p:sld>
 </file>
 
@@ -4110,13 +4041,6 @@
               </a:rPr>
               <a:t>昇到榮光明宮安然時</a:t>
             </a:r>
-            <a:endParaRPr lang="zh-CN" altLang="zh-TW" sz="6400" b="1" dirty="0">
-              <a:solidFill>
-                <a:srgbClr val="000066"/>
-              </a:solidFill>
-              <a:latin typeface="Microsoft JhengHei" panose="020B0604030504040204" pitchFamily="34" charset="-120"/>
-              <a:ea typeface="Microsoft JhengHei" panose="020B0604030504040204" pitchFamily="34" charset="-120"/>
-            </a:endParaRPr>
           </a:p>
         </p:txBody>
       </p:sp>
@@ -4140,42 +4064,26 @@
           <a:bodyPr wrap="square" rtlCol="0" anchor="ctr">
             <a:spAutoFit/>
           </a:bodyPr>
-          <a:lstStyle/>
-          <a:p>
-            <a:pPr algn="ctr"/>
-            <a:r>
-              <a:rPr lang="en-US" sz="4800" b="1" dirty="0">
+          <a:lstStyle>
+            <a:defPPr>
+              <a:defRPr lang="zh-TW"/>
+            </a:defPPr>
+            <a:lvl1pPr algn="ctr">
+              <a:defRPr sz="3600" b="1">
                 <a:solidFill>
                   <a:srgbClr val="000066"/>
                 </a:solidFill>
                 <a:effectLst/>
-              </a:rPr>
-              <a:t>( </a:t>
-            </a:r>
-            <a:r>
-              <a:rPr lang="en-US" sz="4800" b="1" dirty="0">
-                <a:solidFill>
-                  <a:srgbClr val="000066"/>
-                </a:solidFill>
-                <a:effectLst/>
-              </a:rPr>
-              <a:t>3 </a:t>
-            </a:r>
-            <a:r>
-              <a:rPr lang="en-US" sz="4800" b="1" dirty="0">
-                <a:solidFill>
-                  <a:srgbClr val="000066"/>
-                </a:solidFill>
-                <a:effectLst/>
-              </a:rPr>
-              <a:t>)</a:t>
-            </a:r>
-            <a:endParaRPr lang="vi-VN" sz="4800" b="1" dirty="0">
-              <a:solidFill>
-                <a:srgbClr val="000066"/>
-              </a:solidFill>
-              <a:effectLst/>
-            </a:endParaRPr>
+                <a:latin typeface="+mj-lt"/>
+              </a:defRPr>
+            </a:lvl1pPr>
+          </a:lstStyle>
+          <a:p>
+            <a:r>
+              <a:rPr lang="en-US" dirty="0"/>
+              <a:t>( 3 / 3 )</a:t>
+            </a:r>
+            <a:endParaRPr lang="vi-VN" dirty="0"/>
           </a:p>
         </p:txBody>
       </p:sp>
@@ -4189,13 +4097,6 @@
   <p:clrMapOvr>
     <a:masterClrMapping/>
   </p:clrMapOvr>
-  <p:timing>
-    <p:tnLst>
-      <p:par>
-        <p:cTn id="1" dur="indefinite" restart="never" nodeType="tmRoot"/>
-      </p:par>
-    </p:tnLst>
-  </p:timing>
 </p:sld>
 </file>
 
@@ -4266,13 +4167,6 @@
               </a:rPr>
               <a:t>望主血潔净保守</a:t>
             </a:r>
-            <a:endParaRPr lang="zh-CN" altLang="zh-TW" sz="6400" b="1" dirty="0">
-              <a:solidFill>
-                <a:srgbClr val="000066"/>
-              </a:solidFill>
-              <a:latin typeface="Microsoft JhengHei" panose="020B0604030504040204" pitchFamily="34" charset="-120"/>
-              <a:ea typeface="Microsoft JhengHei" panose="020B0604030504040204" pitchFamily="34" charset="-120"/>
-            </a:endParaRPr>
           </a:p>
         </p:txBody>
       </p:sp>
@@ -4286,13 +4180,6 @@
   <p:clrMapOvr>
     <a:masterClrMapping/>
   </p:clrMapOvr>
-  <p:timing>
-    <p:tnLst>
-      <p:par>
-        <p:cTn id="1" dur="indefinite" restart="never" nodeType="tmRoot"/>
-      </p:par>
-    </p:tnLst>
-  </p:timing>
 </p:sld>
 </file>
 
@@ -4383,13 +4270,6 @@
               </a:rPr>
               <a:t>步</a:t>
             </a:r>
-            <a:endParaRPr lang="zh-CN" altLang="zh-TW" sz="6400" b="1" dirty="0">
-              <a:solidFill>
-                <a:srgbClr val="000066"/>
-              </a:solidFill>
-              <a:latin typeface="Microsoft JhengHei" panose="020B0604030504040204" pitchFamily="34" charset="-120"/>
-              <a:ea typeface="Microsoft JhengHei" panose="020B0604030504040204" pitchFamily="34" charset="-120"/>
-            </a:endParaRPr>
           </a:p>
         </p:txBody>
       </p:sp>
@@ -4403,13 +4283,6 @@
   <p:clrMapOvr>
     <a:masterClrMapping/>
   </p:clrMapOvr>
-  <p:timing>
-    <p:tnLst>
-      <p:par>
-        <p:cTn id="1" dur="indefinite" restart="never" nodeType="tmRoot"/>
-      </p:par>
-    </p:tnLst>
-  </p:timing>
 </p:sld>
 </file>
 
@@ -4480,13 +4353,6 @@
               </a:rPr>
               <a:t>我今專心親近親近你</a:t>
             </a:r>
-            <a:endParaRPr lang="zh-CN" altLang="zh-TW" sz="6400" b="1" dirty="0">
-              <a:solidFill>
-                <a:srgbClr val="000066"/>
-              </a:solidFill>
-              <a:latin typeface="Microsoft JhengHei" panose="020B0604030504040204" pitchFamily="34" charset="-120"/>
-              <a:ea typeface="Microsoft JhengHei" panose="020B0604030504040204" pitchFamily="34" charset="-120"/>
-            </a:endParaRPr>
           </a:p>
         </p:txBody>
       </p:sp>
@@ -4498,8 +4364,8 @@
         </p:nvSpPr>
         <p:spPr>
           <a:xfrm>
-            <a:off x="0" y="5157193"/>
-            <a:ext cx="12192000" cy="830997"/>
+            <a:off x="0" y="5249525"/>
+            <a:ext cx="12192000" cy="646331"/>
           </a:xfrm>
           <a:prstGeom prst="rect">
             <a:avLst/>
@@ -4514,19 +4380,21 @@
           <a:p>
             <a:pPr algn="ctr"/>
             <a:r>
-              <a:rPr lang="en-US" sz="4800" b="1" dirty="0">
+              <a:rPr lang="en-US" sz="3600" b="1" dirty="0">
                 <a:solidFill>
                   <a:srgbClr val="000066"/>
                 </a:solidFill>
                 <a:effectLst/>
+                <a:latin typeface="+mj-lt"/>
               </a:rPr>
-              <a:t>( 1 )</a:t>
-            </a:r>
-            <a:endParaRPr lang="vi-VN" sz="4800" b="1" dirty="0">
+              <a:t>( 1 / 3 )</a:t>
+            </a:r>
+            <a:endParaRPr lang="vi-VN" sz="3600" b="1" dirty="0">
               <a:solidFill>
                 <a:srgbClr val="000066"/>
               </a:solidFill>
               <a:effectLst/>
+              <a:latin typeface="+mj-lt"/>
             </a:endParaRPr>
           </a:p>
         </p:txBody>
@@ -4541,13 +4409,6 @@
   <p:clrMapOvr>
     <a:masterClrMapping/>
   </p:clrMapOvr>
-  <p:timing>
-    <p:tnLst>
-      <p:par>
-        <p:cTn id="1" dur="indefinite" restart="never" nodeType="tmRoot"/>
-      </p:par>
-    </p:tnLst>
-  </p:timing>
 </p:sld>
 </file>
 
@@ -4618,13 +4479,6 @@
               </a:rPr>
               <a:t>致我常能親近主到底</a:t>
             </a:r>
-            <a:endParaRPr lang="zh-CN" altLang="zh-TW" sz="6400" b="1" dirty="0">
-              <a:solidFill>
-                <a:srgbClr val="000066"/>
-              </a:solidFill>
-              <a:latin typeface="Microsoft JhengHei" panose="020B0604030504040204" pitchFamily="34" charset="-120"/>
-              <a:ea typeface="Microsoft JhengHei" panose="020B0604030504040204" pitchFamily="34" charset="-120"/>
-            </a:endParaRPr>
           </a:p>
         </p:txBody>
       </p:sp>
@@ -4648,24 +4502,26 @@
           <a:bodyPr wrap="square" rtlCol="0" anchor="ctr">
             <a:spAutoFit/>
           </a:bodyPr>
-          <a:lstStyle/>
-          <a:p>
-            <a:pPr algn="ctr"/>
-            <a:r>
-              <a:rPr lang="en-US" sz="4800" b="1" dirty="0">
+          <a:lstStyle>
+            <a:defPPr>
+              <a:defRPr lang="zh-TW"/>
+            </a:defPPr>
+            <a:lvl1pPr algn="ctr">
+              <a:defRPr sz="3600" b="1">
                 <a:solidFill>
                   <a:srgbClr val="000066"/>
                 </a:solidFill>
                 <a:effectLst/>
-              </a:rPr>
-              <a:t>( 1 )</a:t>
-            </a:r>
-            <a:endParaRPr lang="vi-VN" sz="4800" b="1" dirty="0">
-              <a:solidFill>
-                <a:srgbClr val="000066"/>
-              </a:solidFill>
-              <a:effectLst/>
-            </a:endParaRPr>
+                <a:latin typeface="+mj-lt"/>
+              </a:defRPr>
+            </a:lvl1pPr>
+          </a:lstStyle>
+          <a:p>
+            <a:r>
+              <a:rPr lang="en-US" dirty="0"/>
+              <a:t>( 1 / 3 )</a:t>
+            </a:r>
+            <a:endParaRPr lang="vi-VN" dirty="0"/>
           </a:p>
         </p:txBody>
       </p:sp>
@@ -4679,13 +4535,6 @@
   <p:clrMapOvr>
     <a:masterClrMapping/>
   </p:clrMapOvr>
-  <p:timing>
-    <p:tnLst>
-      <p:par>
-        <p:cTn id="1" dur="indefinite" restart="never" nodeType="tmRoot"/>
-      </p:par>
-    </p:tnLst>
-  </p:timing>
 </p:sld>
 </file>
 
@@ -4756,13 +4605,6 @@
               </a:rPr>
               <a:t>望主血潔净保守</a:t>
             </a:r>
-            <a:endParaRPr lang="zh-CN" altLang="zh-TW" sz="6400" b="1" dirty="0">
-              <a:solidFill>
-                <a:srgbClr val="000066"/>
-              </a:solidFill>
-              <a:latin typeface="Microsoft JhengHei" panose="020B0604030504040204" pitchFamily="34" charset="-120"/>
-              <a:ea typeface="Microsoft JhengHei" panose="020B0604030504040204" pitchFamily="34" charset="-120"/>
-            </a:endParaRPr>
           </a:p>
         </p:txBody>
       </p:sp>
@@ -4776,13 +4618,6 @@
   <p:clrMapOvr>
     <a:masterClrMapping/>
   </p:clrMapOvr>
-  <p:timing>
-    <p:tnLst>
-      <p:par>
-        <p:cTn id="1" dur="indefinite" restart="never" nodeType="tmRoot"/>
-      </p:par>
-    </p:tnLst>
-  </p:timing>
 </p:sld>
 </file>
 
@@ -4873,13 +4708,6 @@
               </a:rPr>
               <a:t>步</a:t>
             </a:r>
-            <a:endParaRPr lang="zh-CN" altLang="zh-TW" sz="6400" b="1" dirty="0">
-              <a:solidFill>
-                <a:srgbClr val="000066"/>
-              </a:solidFill>
-              <a:latin typeface="Microsoft JhengHei" panose="020B0604030504040204" pitchFamily="34" charset="-120"/>
-              <a:ea typeface="Microsoft JhengHei" panose="020B0604030504040204" pitchFamily="34" charset="-120"/>
-            </a:endParaRPr>
           </a:p>
         </p:txBody>
       </p:sp>
@@ -4893,13 +4721,6 @@
   <p:clrMapOvr>
     <a:masterClrMapping/>
   </p:clrMapOvr>
-  <p:timing>
-    <p:tnLst>
-      <p:par>
-        <p:cTn id="1" dur="indefinite" restart="never" nodeType="tmRoot"/>
-      </p:par>
-    </p:tnLst>
-  </p:timing>
 </p:sld>
 </file>
 
@@ -4970,13 +4791,6 @@
               </a:rPr>
               <a:t>溫柔耶穌領我行天路</a:t>
             </a:r>
-            <a:endParaRPr lang="zh-CN" altLang="zh-TW" sz="6400" b="1" dirty="0">
-              <a:solidFill>
-                <a:srgbClr val="000066"/>
-              </a:solidFill>
-              <a:latin typeface="Microsoft JhengHei" panose="020B0604030504040204" pitchFamily="34" charset="-120"/>
-              <a:ea typeface="Microsoft JhengHei" panose="020B0604030504040204" pitchFamily="34" charset="-120"/>
-            </a:endParaRPr>
           </a:p>
         </p:txBody>
       </p:sp>
@@ -5000,42 +4814,26 @@
           <a:bodyPr wrap="square" rtlCol="0" anchor="ctr">
             <a:spAutoFit/>
           </a:bodyPr>
-          <a:lstStyle/>
-          <a:p>
-            <a:pPr algn="ctr"/>
-            <a:r>
-              <a:rPr lang="en-US" sz="4800" b="1" dirty="0">
+          <a:lstStyle>
+            <a:defPPr>
+              <a:defRPr lang="zh-TW"/>
+            </a:defPPr>
+            <a:lvl1pPr algn="ctr">
+              <a:defRPr sz="3600" b="1">
                 <a:solidFill>
                   <a:srgbClr val="000066"/>
                 </a:solidFill>
                 <a:effectLst/>
-              </a:rPr>
-              <a:t>( </a:t>
-            </a:r>
-            <a:r>
-              <a:rPr lang="en-US" sz="4800" b="1" dirty="0">
-                <a:solidFill>
-                  <a:srgbClr val="000066"/>
-                </a:solidFill>
-                <a:effectLst/>
-              </a:rPr>
-              <a:t>2 </a:t>
-            </a:r>
-            <a:r>
-              <a:rPr lang="en-US" sz="4800" b="1" dirty="0">
-                <a:solidFill>
-                  <a:srgbClr val="000066"/>
-                </a:solidFill>
-                <a:effectLst/>
-              </a:rPr>
-              <a:t>)</a:t>
-            </a:r>
-            <a:endParaRPr lang="vi-VN" sz="4800" b="1" dirty="0">
-              <a:solidFill>
-                <a:srgbClr val="000066"/>
-              </a:solidFill>
-              <a:effectLst/>
-            </a:endParaRPr>
+                <a:latin typeface="+mj-lt"/>
+              </a:defRPr>
+            </a:lvl1pPr>
+          </a:lstStyle>
+          <a:p>
+            <a:r>
+              <a:rPr lang="en-US" dirty="0"/>
+              <a:t>( 2 / 3 )</a:t>
+            </a:r>
+            <a:endParaRPr lang="vi-VN" dirty="0"/>
           </a:p>
         </p:txBody>
       </p:sp>
@@ -5049,13 +4847,6 @@
   <p:clrMapOvr>
     <a:masterClrMapping/>
   </p:clrMapOvr>
-  <p:timing>
-    <p:tnLst>
-      <p:par>
-        <p:cTn id="1" dur="indefinite" restart="never" nodeType="tmRoot"/>
-      </p:par>
-    </p:tnLst>
-  </p:timing>
 </p:sld>
 </file>
 
@@ -5126,13 +4917,6 @@
               </a:rPr>
               <a:t>領我跟主永不行錯路</a:t>
             </a:r>
-            <a:endParaRPr lang="zh-CN" altLang="zh-TW" sz="6400" b="1" dirty="0">
-              <a:solidFill>
-                <a:srgbClr val="000066"/>
-              </a:solidFill>
-              <a:latin typeface="Microsoft JhengHei" panose="020B0604030504040204" pitchFamily="34" charset="-120"/>
-              <a:ea typeface="Microsoft JhengHei" panose="020B0604030504040204" pitchFamily="34" charset="-120"/>
-            </a:endParaRPr>
           </a:p>
         </p:txBody>
       </p:sp>
@@ -5156,42 +4940,26 @@
           <a:bodyPr wrap="square" rtlCol="0" anchor="ctr">
             <a:spAutoFit/>
           </a:bodyPr>
-          <a:lstStyle/>
-          <a:p>
-            <a:pPr algn="ctr"/>
-            <a:r>
-              <a:rPr lang="en-US" sz="4800" b="1" dirty="0">
+          <a:lstStyle>
+            <a:defPPr>
+              <a:defRPr lang="zh-TW"/>
+            </a:defPPr>
+            <a:lvl1pPr algn="ctr">
+              <a:defRPr sz="3600" b="1">
                 <a:solidFill>
                   <a:srgbClr val="000066"/>
                 </a:solidFill>
                 <a:effectLst/>
-              </a:rPr>
-              <a:t>( </a:t>
-            </a:r>
-            <a:r>
-              <a:rPr lang="en-US" sz="4800" b="1" dirty="0">
-                <a:solidFill>
-                  <a:srgbClr val="000066"/>
-                </a:solidFill>
-                <a:effectLst/>
-              </a:rPr>
-              <a:t>2 </a:t>
-            </a:r>
-            <a:r>
-              <a:rPr lang="en-US" sz="4800" b="1" dirty="0">
-                <a:solidFill>
-                  <a:srgbClr val="000066"/>
-                </a:solidFill>
-                <a:effectLst/>
-              </a:rPr>
-              <a:t>)</a:t>
-            </a:r>
-            <a:endParaRPr lang="vi-VN" sz="4800" b="1" dirty="0">
-              <a:solidFill>
-                <a:srgbClr val="000066"/>
-              </a:solidFill>
-              <a:effectLst/>
-            </a:endParaRPr>
+                <a:latin typeface="+mj-lt"/>
+              </a:defRPr>
+            </a:lvl1pPr>
+          </a:lstStyle>
+          <a:p>
+            <a:r>
+              <a:rPr lang="en-US" dirty="0"/>
+              <a:t>( 2 / 3 )</a:t>
+            </a:r>
+            <a:endParaRPr lang="vi-VN" dirty="0"/>
           </a:p>
         </p:txBody>
       </p:sp>
@@ -5205,13 +4973,6 @@
   <p:clrMapOvr>
     <a:masterClrMapping/>
   </p:clrMapOvr>
-  <p:timing>
-    <p:tnLst>
-      <p:par>
-        <p:cTn id="1" dur="indefinite" restart="never" nodeType="tmRoot"/>
-      </p:par>
-    </p:tnLst>
-  </p:timing>
 </p:sld>
 </file>
 
@@ -5282,13 +5043,6 @@
               </a:rPr>
               <a:t>望主血潔净保守</a:t>
             </a:r>
-            <a:endParaRPr lang="zh-CN" altLang="zh-TW" sz="6400" b="1" dirty="0">
-              <a:solidFill>
-                <a:srgbClr val="000066"/>
-              </a:solidFill>
-              <a:latin typeface="Microsoft JhengHei" panose="020B0604030504040204" pitchFamily="34" charset="-120"/>
-              <a:ea typeface="Microsoft JhengHei" panose="020B0604030504040204" pitchFamily="34" charset="-120"/>
-            </a:endParaRPr>
           </a:p>
         </p:txBody>
       </p:sp>
@@ -5302,13 +5056,6 @@
   <p:clrMapOvr>
     <a:masterClrMapping/>
   </p:clrMapOvr>
-  <p:timing>
-    <p:tnLst>
-      <p:par>
-        <p:cTn id="1" dur="indefinite" restart="never" nodeType="tmRoot"/>
-      </p:par>
-    </p:tnLst>
-  </p:timing>
 </p:sld>
 </file>
 
@@ -5399,13 +5146,6 @@
               </a:rPr>
               <a:t>步</a:t>
             </a:r>
-            <a:endParaRPr lang="zh-CN" altLang="zh-TW" sz="6400" b="1" dirty="0">
-              <a:solidFill>
-                <a:srgbClr val="000066"/>
-              </a:solidFill>
-              <a:latin typeface="Microsoft JhengHei" panose="020B0604030504040204" pitchFamily="34" charset="-120"/>
-              <a:ea typeface="Microsoft JhengHei" panose="020B0604030504040204" pitchFamily="34" charset="-120"/>
-            </a:endParaRPr>
           </a:p>
         </p:txBody>
       </p:sp>
@@ -5419,13 +5159,6 @@
   <p:clrMapOvr>
     <a:masterClrMapping/>
   </p:clrMapOvr>
-  <p:timing>
-    <p:tnLst>
-      <p:par>
-        <p:cTn id="1" dur="indefinite" restart="never" nodeType="tmRoot"/>
-      </p:par>
-    </p:tnLst>
-  </p:timing>
 </p:sld>
 </file>
 

</xml_diff>